<commit_message>
docs: add the word-for-word live script for rehearsal and the webinar
live-script.pdf is the presenter's single reference: every line to say,
every command and prompt, clock checkpoints, a recovery card, and the
reset checklist. Demo 3 now builds the cloud environment live, which
moves Slide 4 to 22:00-24:00, Demo 3 to 24:00-31:00, Slide 5 to
31:00-32:30, and Demo 4 to 32:30-35:00.

The script uses the real /permissions menu labels and profile header
seen on Codex CLI 0.154.0-alpha.6.2, plans for a thumbs-up-only review
as seen on fallback PR #8, and points older docs and the deck notes at
the new timing.
</commit_message>
<xml_diff>
--- a/docs/presentation/nine-ways-to-run-an-agent.pptx
+++ b/docs/presentation/nine-ways-to-run-an-agent.pptx
@@ -506,7 +506,7 @@
           <a:p>
             <a:r>
               <a:rPr lang="en-US" dirty="0"/>
-              <a:t>0:00–4:00
+              <a:t>0:00–4:00 · Full script: docs/presentation/live-script.pdf
 Opening frame: most developers use Codex as a chat box that happens to sit in a terminal. This session is the configuration layer underneath it: what the agent is allowed to touch, what it reads first, and where the work runs.
 Who it's for: you've installed Codex and asked it to fix a bug, you approve every prompt by hand, you've heard of AGENTS.md but never checked it's read, and you're not sure when to use the cloud. Nobody needs to have written a config file.
 Read the four take-aways out loud.
@@ -603,7 +603,7 @@
 Say it twice: sandbox is blast radius, approval is interruptions. A tight sandbox with 'never' is still safe. A loose sandbox with 'never' is not.
 Be honest that most of the nine aren't worth using. Counting to nine and finding three worth using is the lesson; the skill is choosing, not memorising.
 If asked: 'untrusted' is deprecated in current Codex; use on-request.
-DEMO 1: (1) read-only + never, ask for the crash fix, it can't write. (2) /permissions to workspace-write + on-request, it fixes and tests with no prompts. (3) ask it to run npm view react version, it asks you. (4) restart with --approve-for-me, same request, a reviewer agent answers. Name danger-full-access + never (--yolo), don't run it. Recovery: Ctrl+C, git reset --hard origin/demo/needs-work.</a:t>
+DEMO 1: (1) read-only + never, ask for the crash fix, it can't write. (2) /permissions → 1. Ask for approval (workspace-write + on-request), it fixes and tests with no prompts. (3) ask it to run npm view react version, it asks you. (4) /permissions → 2. Approve for me (same as --approve-for-me), same request, a reviewer agent answers. Name danger-full-access + never (--yolo), don't run it. Recovery: Ctrl+C, git reset --hard origin/demo/needs-work.</a:t>
             </a:r>
             <a:endParaRPr lang="en-US" dirty="0"/>
           </a:p>
@@ -782,11 +782,11 @@
           <a:p>
             <a:r>
               <a:rPr lang="en-US" dirty="0"/>
-              <a:t>22:00–25:00, then DEMO 3 25:00–30:00
+              <a:t>22:00–24:00, then DEMO 3 24:00–31:00
 One agent, three surfaces. The judgment call: offload work that is well specified and slow; keep work that needs your eyes, local state, or fast iteration. Ask the room what they'd offload. Good answers: dependency bumps, test backfill, mechanical refactors.
 Two phases: setup runs your script with internet and secrets; secrets are removed; the agent phase has no network by default, but environment variables remain. So install dependencies in setup, not in the task. This is the highest-value slide for anyone who's hit a confusing cloud failure; budget an extra minute for questions.
 Failure mode to name: offloading work that needed your local database.
-DEMO 3: show the environment settings (setup npm ci, agent internet off). Start Task A first (fix the crash + missing regression test) and leave it running. Start Task B (run npm view react version): it fails with a network error. Line: 'Task B didn't break. It's working exactly as configured.'</a:t>
+DEMO 3: create a new environment live (sprintboard-live: repository sprintboard-webinar, branch demo/needs-work, Node 22, setup script npm ci, agent internet off). Start Task A first (fix the crash + missing regression test) and leave it running. Start Task B (run npm view react version): it fails with a network error. Line: 'Task B didn't break. It's working exactly as configured.'</a:t>
             </a:r>
             <a:endParaRPr lang="en-US" dirty="0"/>
           </a:p>
@@ -874,11 +874,11 @@
           <a:p>
             <a:r>
               <a:rPr lang="en-US" dirty="0"/>
-              <a:t>30:00–31:30, then DEMO 4 31:30–34:00, then questions
+              <a:t>31:00–32:30, then DEMO 4 32:30–35:00 (Task A decision at 32:30), then questions 35:00–40:00
 Codex reviews pull requests and follows the Code Review Rules in AGENTS.md, automatically or when you comment @codex review. Run it before a human sees the branch. Emphasise critical reading: the failure mode for juniors is accepting every suggestion, which is how you get worse code with more confidence.
 Model lanes: Luna for mechanical work, Terra for everyday repository work, Sol for debugging and ambiguity, Astra for long multi-tool work. Don't read version numbers aloud; they date the recording. Profiles are files in ~/.codex, selected with codex -p.
 Failure modes: trusting an agent's own claim that the tests pass (point at the CI check), and one long thread doing four unrelated tasks (every demo today started fresh).
-DEMO 4: create the pull request from Task A against demo/needs-work; the automatic review posts (or comment @codex review); read one finding aloud and say whether you agree. If time: codex -p fast for a mechanical rename.
+DEMO 4: create the pull request from Task A against demo/needs-work; the automatic review posts (or comment @codex review); read one finding aloud and say whether you agree. If it only leaves a thumbs-up, explain why the diff passes the blocking rules and point at the CI check. If time: codex -p fast for a mechanical rename.
 Close: 'Configure the leash once, and the agent stops needing supervision for the boring 80%.' Questions.</a:t>
             </a:r>
             <a:endParaRPr lang="en-US" dirty="0"/>

</xml_diff>